<commit_message>
Update PFA defense materials
Refresh the final Synkro PFA presentation and report documents. This update incorporates revised content and final deliverable versions for the defense and report submissions.
</commit_message>
<xml_diff>
--- a/Synkro_PFA_Defense.pptx
+++ b/Synkro_PFA_Defense.pptx
@@ -15,6 +15,7 @@
     <p:sldId id="260" r:id="rId6"/>
     <p:sldId id="261" r:id="rId7"/>
     <p:sldId id="262" r:id="rId8"/>
+    <p:sldId id="275" r:id="rId26"/>
     <p:sldId id="263" r:id="rId9"/>
     <p:sldId id="264" r:id="rId10"/>
     <p:sldId id="265" r:id="rId11"/>
@@ -2538,7 +2539,7 @@
         <p:spPr>
           <a:xfrm>
             <a:off x="0" y="6784848"/>
-            <a:ext cx="641668" cy="41148"/>
+            <a:ext cx="609585" cy="41148"/>
           </a:xfrm>
           <a:prstGeom prst="rect">
             <a:avLst/>
@@ -2589,7 +2590,7 @@
                 <a:ea typeface="Calibri" pitchFamily="34" charset="-122"/>
                 <a:cs typeface="Calibri" pitchFamily="34" charset="-120"/>
               </a:rPr>
-              <a:t>01 / 19</a:t>
+              <a:t>01 / 20</a:t>
             </a:r>
             <a:endParaRPr lang="en-US" sz="1000" dirty="0"/>
           </a:p>
@@ -2664,7 +2665,7 @@
         <p:spPr>
           <a:xfrm>
             <a:off x="0" y="6784848"/>
-            <a:ext cx="6416682" cy="41148"/>
+            <a:ext cx="6705432" cy="41148"/>
           </a:xfrm>
           <a:prstGeom prst="rect">
             <a:avLst/>
@@ -2715,7 +2716,7 @@
                 <a:ea typeface="Calibri" pitchFamily="34" charset="-122"/>
                 <a:cs typeface="Calibri" pitchFamily="34" charset="-120"/>
               </a:rPr>
-              <a:t>10 / 19</a:t>
+              <a:t>11 / 20</a:t>
             </a:r>
             <a:endParaRPr lang="en-US" sz="1000" dirty="0"/>
           </a:p>
@@ -3236,7 +3237,7 @@
         <p:spPr>
           <a:xfrm>
             <a:off x="0" y="6784848"/>
-            <a:ext cx="7058350" cy="41148"/>
+            <a:ext cx="7315017" cy="41148"/>
           </a:xfrm>
           <a:prstGeom prst="rect">
             <a:avLst/>
@@ -3287,7 +3288,7 @@
                 <a:ea typeface="Calibri" pitchFamily="34" charset="-122"/>
                 <a:cs typeface="Calibri" pitchFamily="34" charset="-120"/>
               </a:rPr>
-              <a:t>11 / 19</a:t>
+              <a:t>12 / 20</a:t>
             </a:r>
             <a:endParaRPr lang="en-US" sz="1000" dirty="0"/>
           </a:p>
@@ -3808,7 +3809,7 @@
         <p:spPr>
           <a:xfrm>
             <a:off x="0" y="6784848"/>
-            <a:ext cx="7700018" cy="41148"/>
+            <a:ext cx="7924602" cy="41148"/>
           </a:xfrm>
           <a:prstGeom prst="rect">
             <a:avLst/>
@@ -3859,7 +3860,7 @@
                 <a:ea typeface="Calibri" pitchFamily="34" charset="-122"/>
                 <a:cs typeface="Calibri" pitchFamily="34" charset="-120"/>
               </a:rPr>
-              <a:t>12 / 19</a:t>
+              <a:t>13 / 20</a:t>
             </a:r>
             <a:endParaRPr lang="en-US" sz="1000" dirty="0"/>
           </a:p>
@@ -4380,7 +4381,7 @@
         <p:spPr>
           <a:xfrm>
             <a:off x="0" y="6784848"/>
-            <a:ext cx="8341686" cy="41148"/>
+            <a:ext cx="8534186" cy="41148"/>
           </a:xfrm>
           <a:prstGeom prst="rect">
             <a:avLst/>
@@ -4431,7 +4432,7 @@
                 <a:ea typeface="Calibri" pitchFamily="34" charset="-122"/>
                 <a:cs typeface="Calibri" pitchFamily="34" charset="-120"/>
               </a:rPr>
-              <a:t>13 / 19</a:t>
+              <a:t>14 / 20</a:t>
             </a:r>
             <a:endParaRPr lang="en-US" sz="1000" dirty="0"/>
           </a:p>
@@ -4952,7 +4953,7 @@
         <p:spPr>
           <a:xfrm>
             <a:off x="0" y="6784848"/>
-            <a:ext cx="8983354" cy="41148"/>
+            <a:ext cx="9143771" cy="41148"/>
           </a:xfrm>
           <a:prstGeom prst="rect">
             <a:avLst/>
@@ -5003,7 +5004,7 @@
                 <a:ea typeface="Calibri" pitchFamily="34" charset="-122"/>
                 <a:cs typeface="Calibri" pitchFamily="34" charset="-120"/>
               </a:rPr>
-              <a:t>14 / 19</a:t>
+              <a:t>15 / 20</a:t>
             </a:r>
             <a:endParaRPr lang="en-US" sz="1000" dirty="0"/>
           </a:p>
@@ -5181,7 +5182,7 @@
         <p:spPr>
           <a:xfrm>
             <a:off x="0" y="6784848"/>
-            <a:ext cx="9625023" cy="41148"/>
+            <a:ext cx="9753356" cy="41148"/>
           </a:xfrm>
           <a:prstGeom prst="rect">
             <a:avLst/>
@@ -5232,7 +5233,7 @@
                 <a:ea typeface="Calibri" pitchFamily="34" charset="-122"/>
                 <a:cs typeface="Calibri" pitchFamily="34" charset="-120"/>
               </a:rPr>
-              <a:t>15 / 19</a:t>
+              <a:t>16 / 20</a:t>
             </a:r>
             <a:endParaRPr lang="en-US" sz="1000" dirty="0"/>
           </a:p>
@@ -5852,7 +5853,7 @@
         <p:spPr>
           <a:xfrm>
             <a:off x="0" y="6784848"/>
-            <a:ext cx="10266691" cy="41148"/>
+            <a:ext cx="10362941" cy="41148"/>
           </a:xfrm>
           <a:prstGeom prst="rect">
             <a:avLst/>
@@ -5903,7 +5904,7 @@
                 <a:ea typeface="Calibri" pitchFamily="34" charset="-122"/>
                 <a:cs typeface="Calibri" pitchFamily="34" charset="-120"/>
               </a:rPr>
-              <a:t>16 / 19</a:t>
+              <a:t>17 / 20</a:t>
             </a:r>
             <a:endParaRPr lang="en-US" sz="1000" dirty="0"/>
           </a:p>
@@ -6504,7 +6505,7 @@
         <p:spPr>
           <a:xfrm>
             <a:off x="0" y="6784848"/>
-            <a:ext cx="10908359" cy="41148"/>
+            <a:ext cx="10972526" cy="41148"/>
           </a:xfrm>
           <a:prstGeom prst="rect">
             <a:avLst/>
@@ -6555,7 +6556,7 @@
                 <a:ea typeface="Calibri" pitchFamily="34" charset="-122"/>
                 <a:cs typeface="Calibri" pitchFamily="34" charset="-120"/>
               </a:rPr>
-              <a:t>17 / 19</a:t>
+              <a:t>18 / 20</a:t>
             </a:r>
             <a:endParaRPr lang="en-US" sz="1000" dirty="0"/>
           </a:p>
@@ -7512,7 +7513,7 @@
         <p:spPr>
           <a:xfrm>
             <a:off x="0" y="6784848"/>
-            <a:ext cx="11550027" cy="41148"/>
+            <a:ext cx="11582110" cy="41148"/>
           </a:xfrm>
           <a:prstGeom prst="rect">
             <a:avLst/>
@@ -7563,7 +7564,7 @@
                 <a:ea typeface="Calibri" pitchFamily="34" charset="-122"/>
                 <a:cs typeface="Calibri" pitchFamily="34" charset="-120"/>
               </a:rPr>
-              <a:t>18 / 19</a:t>
+              <a:t>19 / 20</a:t>
             </a:r>
             <a:endParaRPr lang="en-US" sz="1000" dirty="0"/>
           </a:p>
@@ -8049,7 +8050,7 @@
                 <a:ea typeface="Calibri" pitchFamily="34" charset="-122"/>
                 <a:cs typeface="Calibri" pitchFamily="34" charset="-120"/>
               </a:rPr>
-              <a:t>19 / 19</a:t>
+              <a:t>20 / 20</a:t>
             </a:r>
             <a:endParaRPr lang="en-US" sz="1000" dirty="0"/>
           </a:p>
@@ -8124,7 +8125,7 @@
         <p:spPr>
           <a:xfrm>
             <a:off x="0" y="6784848"/>
-            <a:ext cx="1283336" cy="41148"/>
+            <a:ext cx="1219170" cy="41148"/>
           </a:xfrm>
           <a:prstGeom prst="rect">
             <a:avLst/>
@@ -8175,7 +8176,7 @@
                 <a:ea typeface="Calibri" pitchFamily="34" charset="-122"/>
                 <a:cs typeface="Calibri" pitchFamily="34" charset="-120"/>
               </a:rPr>
-              <a:t>02 / 19</a:t>
+              <a:t>02 / 20</a:t>
             </a:r>
             <a:endParaRPr lang="en-US" sz="1000" dirty="0"/>
           </a:p>
@@ -8984,6 +8985,775 @@
                 <a:cs typeface="Calibri" pitchFamily="34" charset="-120"/>
               </a:rPr>
               <a:t>Skills gained, challenges, and where Synkro goes from here</a:t>
+            </a:r>
+            <a:endParaRPr lang="en-US" sz="1250" dirty="0"/>
+          </a:p>
+        </p:txBody>
+      </p:sp>
+    </p:spTree>
+  </p:cSld>
+  <p:clrMapOvr>
+    <a:masterClrMapping/>
+  </p:clrMapOvr>
+</p:sld>
+</file>
+
+<file path=ppt/slides/slide20.xml><?xml version="1.0" encoding="utf-8"?>
+<p:sld xmlns:a="http://schemas.openxmlformats.org/drawingml/2006/main" xmlns:r="http://schemas.openxmlformats.org/officeDocument/2006/relationships" xmlns:p="http://schemas.openxmlformats.org/presentationml/2006/main">
+  <p:cSld name="Slide 16">
+    <p:bg>
+      <p:bgPr>
+        <a:solidFill>
+          <a:srgbClr val="FFFFFF"/>
+        </a:solidFill>
+        <a:effectLst/>
+      </p:bgPr>
+    </p:bg>
+    <p:spTree>
+      <p:nvGrpSpPr>
+        <p:cNvPr id="1" name=""/>
+        <p:cNvGrpSpPr/>
+        <p:nvPr/>
+      </p:nvGrpSpPr>
+      <p:grpSpPr>
+        <a:xfrm>
+          <a:off x="0" y="0"/>
+          <a:ext cx="0" cy="0"/>
+          <a:chOff x="0" y="0"/>
+          <a:chExt cx="0" cy="0"/>
+        </a:xfrm>
+      </p:grpSpPr>
+      <p:sp>
+        <p:nvSpPr>
+          <p:cNvPr id="2" name="Shape 0"/>
+          <p:cNvSpPr/>
+          <p:nvPr/>
+        </p:nvSpPr>
+        <p:spPr>
+          <a:xfrm>
+            <a:off x="0" y="6784848"/>
+            <a:ext cx="12191695" cy="41148"/>
+          </a:xfrm>
+          <a:prstGeom prst="rect">
+            <a:avLst/>
+          </a:prstGeom>
+          <a:solidFill>
+            <a:srgbClr val="E2E4F0"/>
+          </a:solidFill>
+          <a:ln/>
+        </p:spPr>
+        <p:txBody>
+          <a:bodyPr/>
+          <a:lstStyle/>
+          <a:p>
+            <a:endParaRPr lang="en-US"/>
+          </a:p>
+        </p:txBody>
+      </p:sp>
+      <p:sp>
+        <p:nvSpPr>
+          <p:cNvPr id="3" name="Shape 1"/>
+          <p:cNvSpPr/>
+          <p:nvPr/>
+        </p:nvSpPr>
+        <p:spPr>
+          <a:xfrm>
+            <a:off x="0" y="6784848"/>
+            <a:ext cx="4876678" cy="41148"/>
+          </a:xfrm>
+          <a:prstGeom prst="rect">
+            <a:avLst/>
+          </a:prstGeom>
+          <a:solidFill>
+            <a:srgbClr val="4F46E5"/>
+          </a:solidFill>
+          <a:ln/>
+        </p:spPr>
+        <p:txBody>
+          <a:bodyPr/>
+          <a:lstStyle/>
+          <a:p>
+            <a:endParaRPr lang="en-US"/>
+          </a:p>
+        </p:txBody>
+      </p:sp>
+      <p:sp>
+        <p:nvSpPr>
+          <p:cNvPr id="4" name="Text 2"/>
+          <p:cNvSpPr/>
+          <p:nvPr/>
+        </p:nvSpPr>
+        <p:spPr>
+          <a:xfrm>
+            <a:off x="11002975" y="6492240"/>
+            <a:ext cx="1051560" cy="274320"/>
+          </a:xfrm>
+          <a:prstGeom prst="rect">
+            <a:avLst/>
+          </a:prstGeom>
+          <a:noFill/>
+          <a:ln/>
+        </p:spPr>
+        <p:txBody>
+          <a:bodyPr wrap="square" rtlCol="0" anchor="ctr"/>
+          <a:lstStyle/>
+          <a:p>
+            <a:pPr marL="0" indent="0" algn="r">
+              <a:buNone/>
+            </a:pPr>
+            <a:r>
+              <a:rPr lang="en-US" sz="1000" dirty="0">
+                <a:solidFill>
+                  <a:srgbClr val="6B7280"/>
+                </a:solidFill>
+                <a:latin typeface="Calibri" pitchFamily="34" charset="0"/>
+                <a:ea typeface="Calibri" pitchFamily="34" charset="-122"/>
+                <a:cs typeface="Calibri" pitchFamily="34" charset="-120"/>
+              </a:rPr>
+              <a:t>08 / 20</a:t>
+            </a:r>
+            <a:endParaRPr lang="en-US" sz="1000" dirty="0"/>
+          </a:p>
+        </p:txBody>
+      </p:sp>
+      <p:sp>
+        <p:nvSpPr>
+          <p:cNvPr id="5" name="Text 3"/>
+          <p:cNvSpPr/>
+          <p:nvPr/>
+        </p:nvSpPr>
+        <p:spPr>
+          <a:xfrm>
+            <a:off x="548640" y="411480"/>
+            <a:ext cx="7315200" cy="320040"/>
+          </a:xfrm>
+          <a:prstGeom prst="rect">
+            <a:avLst/>
+          </a:prstGeom>
+          <a:noFill/>
+          <a:ln/>
+        </p:spPr>
+        <p:txBody>
+          <a:bodyPr wrap="square" rtlCol="0" anchor="ctr"/>
+          <a:lstStyle/>
+          <a:p>
+            <a:pPr marL="0" indent="0">
+              <a:buNone/>
+            </a:pPr>
+            <a:r>
+              <a:rPr lang="en-US" sz="1200" b="1" kern="0" spc="200" dirty="0">
+                <a:solidFill>
+                  <a:srgbClr val="4F46E5"/>
+                </a:solidFill>
+                <a:latin typeface="Calibri" pitchFamily="34" charset="0"/>
+                <a:ea typeface="Calibri" pitchFamily="34" charset="-122"/>
+                <a:cs typeface="Calibri" pitchFamily="34" charset="-120"/>
+              </a:rPr>
+              <a:t>02 · SOLUTION &amp; METHODOLOGY</a:t>
+            </a:r>
+            <a:endParaRPr lang="en-US" sz="1200" dirty="0"/>
+          </a:p>
+        </p:txBody>
+      </p:sp>
+      <p:sp>
+        <p:nvSpPr>
+          <p:cNvPr id="6" name="Text 4"/>
+          <p:cNvSpPr/>
+          <p:nvPr/>
+        </p:nvSpPr>
+        <p:spPr>
+          <a:xfrm>
+            <a:off x="548640" y="713232"/>
+            <a:ext cx="10515600" cy="777240"/>
+          </a:xfrm>
+          <a:prstGeom prst="rect">
+            <a:avLst/>
+          </a:prstGeom>
+          <a:noFill/>
+          <a:ln/>
+        </p:spPr>
+        <p:txBody>
+          <a:bodyPr wrap="square" rtlCol="0" anchor="ctr"/>
+          <a:lstStyle/>
+          <a:p>
+            <a:pPr marL="0" indent="0">
+              <a:buNone/>
+            </a:pPr>
+            <a:r>
+              <a:rPr lang="en-US" sz="3200" b="1" dirty="0">
+                <a:solidFill>
+                  <a:srgbClr val="1B1F3B"/>
+                </a:solidFill>
+                <a:latin typeface="Cambria" pitchFamily="34" charset="0"/>
+                <a:ea typeface="Cambria" pitchFamily="34" charset="-122"/>
+                <a:cs typeface="Cambria" pitchFamily="34" charset="-120"/>
+              </a:rPr>
+              <a:t>Requirements specification</a:t>
+            </a:r>
+            <a:endParaRPr lang="en-US" sz="3200" dirty="0"/>
+          </a:p>
+        </p:txBody>
+      </p:sp>
+      <p:sp>
+        <p:nvSpPr>
+          <p:cNvPr id="7" name="Shape 5"/>
+          <p:cNvSpPr/>
+          <p:nvPr/>
+        </p:nvSpPr>
+        <p:spPr>
+          <a:xfrm>
+            <a:off x="548640" y="1691640"/>
+            <a:ext cx="5349240" cy="4480560"/>
+          </a:xfrm>
+          <a:prstGeom prst="roundRect">
+            <a:avLst>
+              <a:gd name="adj" fmla="val 1837"/>
+            </a:avLst>
+          </a:prstGeom>
+          <a:solidFill>
+            <a:srgbClr val="F5F6FC"/>
+          </a:solidFill>
+          <a:ln/>
+        </p:spPr>
+        <p:txBody>
+          <a:bodyPr/>
+          <a:lstStyle/>
+          <a:p>
+            <a:endParaRPr lang="en-US"/>
+          </a:p>
+        </p:txBody>
+      </p:sp>
+      <p:sp>
+        <p:nvSpPr>
+          <p:cNvPr id="8" name="Text 6"/>
+          <p:cNvSpPr/>
+          <p:nvPr/>
+        </p:nvSpPr>
+        <p:spPr>
+          <a:xfrm>
+            <a:off x="868680" y="1920240"/>
+            <a:ext cx="4754880" cy="365760"/>
+          </a:xfrm>
+          <a:prstGeom prst="rect">
+            <a:avLst/>
+          </a:prstGeom>
+          <a:noFill/>
+          <a:ln/>
+        </p:spPr>
+        <p:txBody>
+          <a:bodyPr wrap="square" rtlCol="0" anchor="ctr"/>
+          <a:lstStyle/>
+          <a:p>
+            <a:pPr marL="0" indent="0">
+              <a:buNone/>
+            </a:pPr>
+            <a:r>
+              <a:rPr lang="en-US" sz="1600" b="1" dirty="0">
+                <a:solidFill>
+                  <a:srgbClr val="1B1F3B"/>
+                </a:solidFill>
+                <a:latin typeface="Cambria" pitchFamily="34" charset="0"/>
+                <a:ea typeface="Cambria" pitchFamily="34" charset="-122"/>
+                <a:cs typeface="Cambria" pitchFamily="34" charset="-120"/>
+              </a:rPr>
+              <a:t>Functional requirements</a:t>
+            </a:r>
+            <a:endParaRPr lang="en-US" sz="1600" dirty="0"/>
+          </a:p>
+        </p:txBody>
+      </p:sp>
+      <p:sp>
+        <p:nvSpPr>
+          <p:cNvPr id="9" name="Text 7"/>
+          <p:cNvSpPr/>
+          <p:nvPr/>
+        </p:nvSpPr>
+        <p:spPr>
+          <a:xfrm>
+            <a:off x="868680" y="2423160"/>
+            <a:ext cx="4754880" cy="460000"/>
+          </a:xfrm>
+          <a:prstGeom prst="rect">
+            <a:avLst/>
+          </a:prstGeom>
+          <a:noFill/>
+          <a:ln/>
+        </p:spPr>
+        <p:txBody>
+          <a:bodyPr wrap="square" rtlCol="0" anchor="ctr"/>
+          <a:lstStyle/>
+          <a:p>
+            <a:pPr marL="0" indent="0">
+              <a:buNone/>
+            </a:pPr>
+            <a:r>
+              <a:rPr lang="en-US" sz="1250" dirty="0">
+                <a:solidFill>
+                  <a:srgbClr val="1F2430"/>
+                </a:solidFill>
+                <a:latin typeface="Calibri" pitchFamily="34" charset="0"/>
+                <a:ea typeface="Calibri" pitchFamily="34" charset="-122"/>
+                <a:cs typeface="Calibri" pitchFamily="34" charset="-120"/>
+              </a:rPr>
+              <a:t>• Registration, e-mail verification, login &amp; session management</a:t>
+            </a:r>
+            <a:endParaRPr lang="en-US" sz="1250" dirty="0"/>
+          </a:p>
+        </p:txBody>
+      </p:sp>
+      <p:sp>
+        <p:nvSpPr>
+          <p:cNvPr id="10" name="Text 8"/>
+          <p:cNvSpPr/>
+          <p:nvPr/>
+        </p:nvSpPr>
+        <p:spPr>
+          <a:xfrm>
+            <a:off x="868680" y="2913160"/>
+            <a:ext cx="4754880" cy="460000"/>
+          </a:xfrm>
+          <a:prstGeom prst="rect">
+            <a:avLst/>
+          </a:prstGeom>
+          <a:noFill/>
+          <a:ln/>
+        </p:spPr>
+        <p:txBody>
+          <a:bodyPr wrap="square" rtlCol="0" anchor="ctr"/>
+          <a:lstStyle/>
+          <a:p>
+            <a:pPr marL="0" indent="0">
+              <a:buNone/>
+            </a:pPr>
+            <a:r>
+              <a:rPr lang="en-US" sz="1250" dirty="0">
+                <a:solidFill>
+                  <a:srgbClr val="1F2430"/>
+                </a:solidFill>
+                <a:latin typeface="Calibri" pitchFamily="34" charset="0"/>
+                <a:ea typeface="Calibri" pitchFamily="34" charset="-122"/>
+                <a:cs typeface="Calibri" pitchFamily="34" charset="-120"/>
+              </a:rPr>
+              <a:t>• Profile, account settings &amp; visual theme management</a:t>
+            </a:r>
+            <a:endParaRPr lang="en-US" sz="1250" dirty="0"/>
+          </a:p>
+        </p:txBody>
+      </p:sp>
+      <p:sp>
+        <p:nvSpPr>
+          <p:cNvPr id="11" name="Text 9"/>
+          <p:cNvSpPr/>
+          <p:nvPr/>
+        </p:nvSpPr>
+        <p:spPr>
+          <a:xfrm>
+            <a:off x="868680" y="3403160"/>
+            <a:ext cx="4754880" cy="460000"/>
+          </a:xfrm>
+          <a:prstGeom prst="rect">
+            <a:avLst/>
+          </a:prstGeom>
+          <a:noFill/>
+          <a:ln/>
+        </p:spPr>
+        <p:txBody>
+          <a:bodyPr wrap="square" rtlCol="0" anchor="ctr"/>
+          <a:lstStyle/>
+          <a:p>
+            <a:pPr marL="0" indent="0">
+              <a:buNone/>
+            </a:pPr>
+            <a:r>
+              <a:rPr lang="en-US" sz="1250" dirty="0">
+                <a:solidFill>
+                  <a:srgbClr val="1F2430"/>
+                </a:solidFill>
+                <a:latin typeface="Calibri" pitchFamily="34" charset="0"/>
+                <a:ea typeface="Calibri" pitchFamily="34" charset="-122"/>
+                <a:cs typeface="Calibri" pitchFamily="34" charset="-120"/>
+              </a:rPr>
+              <a:t>• Project creation, invitations &amp; role assignment</a:t>
+            </a:r>
+            <a:endParaRPr lang="en-US" sz="1250" dirty="0"/>
+          </a:p>
+        </p:txBody>
+      </p:sp>
+      <p:sp>
+        <p:nvSpPr>
+          <p:cNvPr id="12" name="Text 10"/>
+          <p:cNvSpPr/>
+          <p:nvPr/>
+        </p:nvSpPr>
+        <p:spPr>
+          <a:xfrm>
+            <a:off x="868680" y="3893160"/>
+            <a:ext cx="4754880" cy="460000"/>
+          </a:xfrm>
+          <a:prstGeom prst="rect">
+            <a:avLst/>
+          </a:prstGeom>
+          <a:noFill/>
+          <a:ln/>
+        </p:spPr>
+        <p:txBody>
+          <a:bodyPr wrap="square" rtlCol="0" anchor="ctr"/>
+          <a:lstStyle/>
+          <a:p>
+            <a:pPr marL="0" indent="0">
+              <a:buNone/>
+            </a:pPr>
+            <a:r>
+              <a:rPr lang="en-US" sz="1250" dirty="0">
+                <a:solidFill>
+                  <a:srgbClr val="1F2430"/>
+                </a:solidFill>
+                <a:latin typeface="Calibri" pitchFamily="34" charset="0"/>
+                <a:ea typeface="Calibri" pitchFamily="34" charset="-122"/>
+                <a:cs typeface="Calibri" pitchFamily="34" charset="-120"/>
+              </a:rPr>
+              <a:t>• Task lifecycle: status, checklists &amp; deliverables</a:t>
+            </a:r>
+            <a:endParaRPr lang="en-US" sz="1250" dirty="0"/>
+          </a:p>
+        </p:txBody>
+      </p:sp>
+      <p:sp>
+        <p:nvSpPr>
+          <p:cNvPr id="13" name="Text 11"/>
+          <p:cNvSpPr/>
+          <p:nvPr/>
+        </p:nvSpPr>
+        <p:spPr>
+          <a:xfrm>
+            <a:off x="868680" y="4383160"/>
+            <a:ext cx="4754880" cy="460000"/>
+          </a:xfrm>
+          <a:prstGeom prst="rect">
+            <a:avLst/>
+          </a:prstGeom>
+          <a:noFill/>
+          <a:ln/>
+        </p:spPr>
+        <p:txBody>
+          <a:bodyPr wrap="square" rtlCol="0" anchor="ctr"/>
+          <a:lstStyle/>
+          <a:p>
+            <a:pPr marL="0" indent="0">
+              <a:buNone/>
+            </a:pPr>
+            <a:r>
+              <a:rPr lang="en-US" sz="1250" dirty="0">
+                <a:solidFill>
+                  <a:srgbClr val="1F2430"/>
+                </a:solidFill>
+                <a:latin typeface="Calibri" pitchFamily="34" charset="0"/>
+                <a:ea typeface="Calibri" pitchFamily="34" charset="-122"/>
+                <a:cs typeface="Calibri" pitchFamily="34" charset="-120"/>
+              </a:rPr>
+              <a:t>• Comments, reviewer feedback &amp; real-time notifications</a:t>
+            </a:r>
+            <a:endParaRPr lang="en-US" sz="1250" dirty="0"/>
+          </a:p>
+        </p:txBody>
+      </p:sp>
+      <p:sp>
+        <p:nvSpPr>
+          <p:cNvPr id="101" name="Text 101"/>
+          <p:cNvSpPr/>
+          <p:nvPr/>
+        </p:nvSpPr>
+        <p:spPr>
+          <a:xfrm>
+            <a:off x="868680" y="4873160"/>
+            <a:ext cx="4754880" cy="460000"/>
+          </a:xfrm>
+          <a:prstGeom prst="rect">
+            <a:avLst/>
+          </a:prstGeom>
+          <a:noFill/>
+          <a:ln/>
+        </p:spPr>
+        <p:txBody>
+          <a:bodyPr wrap="square" rtlCol="0" anchor="ctr"/>
+          <a:lstStyle/>
+          <a:p>
+            <a:pPr marL="0" indent="0">
+              <a:buNone/>
+            </a:pPr>
+            <a:r>
+              <a:rPr lang="en-US" sz="1250" dirty="0">
+                <a:solidFill>
+                  <a:srgbClr val="1F2430"/>
+                </a:solidFill>
+                <a:latin typeface="Calibri" pitchFamily="34" charset="0"/>
+                <a:ea typeface="Calibri" pitchFamily="34" charset="-122"/>
+                <a:cs typeface="Calibri" pitchFamily="34" charset="-120"/>
+              </a:rPr>
+              <a:t>• Admin: user management, suspension appeals &amp; analytics</a:t>
+            </a:r>
+            <a:endParaRPr lang="en-US" sz="1250" dirty="0"/>
+          </a:p>
+        </p:txBody>
+      </p:sp>
+      <p:sp>
+        <p:nvSpPr>
+          <p:cNvPr id="14" name="Shape 12"/>
+          <p:cNvSpPr/>
+          <p:nvPr/>
+        </p:nvSpPr>
+        <p:spPr>
+          <a:xfrm>
+            <a:off x="6263640" y="1691640"/>
+            <a:ext cx="5349240" cy="4480560"/>
+          </a:xfrm>
+          <a:prstGeom prst="roundRect">
+            <a:avLst>
+              <a:gd name="adj" fmla="val 1837"/>
+            </a:avLst>
+          </a:prstGeom>
+          <a:solidFill>
+            <a:srgbClr val="1B1F3B"/>
+          </a:solidFill>
+          <a:ln/>
+        </p:spPr>
+        <p:txBody>
+          <a:bodyPr/>
+          <a:lstStyle/>
+          <a:p>
+            <a:endParaRPr lang="en-US"/>
+          </a:p>
+        </p:txBody>
+      </p:sp>
+      <p:sp>
+        <p:nvSpPr>
+          <p:cNvPr id="15" name="Text 13"/>
+          <p:cNvSpPr/>
+          <p:nvPr/>
+        </p:nvSpPr>
+        <p:spPr>
+          <a:xfrm>
+            <a:off x="6583680" y="1920240"/>
+            <a:ext cx="4754880" cy="365760"/>
+          </a:xfrm>
+          <a:prstGeom prst="rect">
+            <a:avLst/>
+          </a:prstGeom>
+          <a:noFill/>
+          <a:ln/>
+        </p:spPr>
+        <p:txBody>
+          <a:bodyPr wrap="square" rtlCol="0" anchor="ctr"/>
+          <a:lstStyle/>
+          <a:p>
+            <a:pPr marL="0" indent="0">
+              <a:buNone/>
+            </a:pPr>
+            <a:r>
+              <a:rPr lang="en-US" sz="1600" b="1" dirty="0">
+                <a:solidFill>
+                  <a:srgbClr val="FFFFFF"/>
+                </a:solidFill>
+                <a:latin typeface="Cambria" pitchFamily="34" charset="0"/>
+                <a:ea typeface="Cambria" pitchFamily="34" charset="-122"/>
+                <a:cs typeface="Cambria" pitchFamily="34" charset="-120"/>
+              </a:rPr>
+              <a:t>Non-functional requirements</a:t>
+            </a:r>
+            <a:endParaRPr lang="en-US" sz="1600" dirty="0"/>
+          </a:p>
+        </p:txBody>
+      </p:sp>
+      <p:sp>
+        <p:nvSpPr>
+          <p:cNvPr id="16" name="Text 14"/>
+          <p:cNvSpPr/>
+          <p:nvPr/>
+        </p:nvSpPr>
+        <p:spPr>
+          <a:xfrm>
+            <a:off x="6583680" y="2423160"/>
+            <a:ext cx="4754880" cy="460000"/>
+          </a:xfrm>
+          <a:prstGeom prst="rect">
+            <a:avLst/>
+          </a:prstGeom>
+          <a:noFill/>
+          <a:ln/>
+        </p:spPr>
+        <p:txBody>
+          <a:bodyPr wrap="square" rtlCol="0" anchor="ctr"/>
+          <a:lstStyle/>
+          <a:p>
+            <a:pPr marL="0" indent="0">
+              <a:buNone/>
+            </a:pPr>
+            <a:r>
+              <a:rPr lang="en-US" sz="1250" dirty="0">
+                <a:solidFill>
+                  <a:srgbClr val="C7CAF2"/>
+                </a:solidFill>
+                <a:latin typeface="Calibri" pitchFamily="34" charset="0"/>
+                <a:ea typeface="Calibri" pitchFamily="34" charset="-122"/>
+                <a:cs typeface="Calibri" pitchFamily="34" charset="-120"/>
+              </a:rPr>
+              <a:t>• Usability: clean, responsive UI on desktop &amp; mobile</a:t>
+            </a:r>
+            <a:endParaRPr lang="en-US" sz="1250" dirty="0"/>
+          </a:p>
+        </p:txBody>
+      </p:sp>
+      <p:sp>
+        <p:nvSpPr>
+          <p:cNvPr id="17" name="Text 15"/>
+          <p:cNvSpPr/>
+          <p:nvPr/>
+        </p:nvSpPr>
+        <p:spPr>
+          <a:xfrm>
+            <a:off x="6583680" y="2913160"/>
+            <a:ext cx="4754880" cy="460000"/>
+          </a:xfrm>
+          <a:prstGeom prst="rect">
+            <a:avLst/>
+          </a:prstGeom>
+          <a:noFill/>
+          <a:ln/>
+        </p:spPr>
+        <p:txBody>
+          <a:bodyPr wrap="square" rtlCol="0" anchor="ctr"/>
+          <a:lstStyle/>
+          <a:p>
+            <a:pPr marL="0" indent="0">
+              <a:buNone/>
+            </a:pPr>
+            <a:r>
+              <a:rPr lang="en-US" sz="1250" dirty="0">
+                <a:solidFill>
+                  <a:srgbClr val="C7CAF2"/>
+                </a:solidFill>
+                <a:latin typeface="Calibri" pitchFamily="34" charset="0"/>
+                <a:ea typeface="Calibri" pitchFamily="34" charset="-122"/>
+                <a:cs typeface="Calibri" pitchFamily="34" charset="-120"/>
+              </a:rPr>
+              <a:t>• Performance: real-time updates with minimal latency</a:t>
+            </a:r>
+            <a:endParaRPr lang="en-US" sz="1250" dirty="0"/>
+          </a:p>
+        </p:txBody>
+      </p:sp>
+      <p:sp>
+        <p:nvSpPr>
+          <p:cNvPr id="18" name="Text 16"/>
+          <p:cNvSpPr/>
+          <p:nvPr/>
+        </p:nvSpPr>
+        <p:spPr>
+          <a:xfrm>
+            <a:off x="6583680" y="3403160"/>
+            <a:ext cx="4754880" cy="460000"/>
+          </a:xfrm>
+          <a:prstGeom prst="rect">
+            <a:avLst/>
+          </a:prstGeom>
+          <a:noFill/>
+          <a:ln/>
+        </p:spPr>
+        <p:txBody>
+          <a:bodyPr wrap="square" rtlCol="0" anchor="ctr"/>
+          <a:lstStyle/>
+          <a:p>
+            <a:pPr marL="0" indent="0">
+              <a:buNone/>
+            </a:pPr>
+            <a:r>
+              <a:rPr lang="en-US" sz="1250" dirty="0">
+                <a:solidFill>
+                  <a:srgbClr val="C7CAF2"/>
+                </a:solidFill>
+                <a:latin typeface="Calibri" pitchFamily="34" charset="0"/>
+                <a:ea typeface="Calibri" pitchFamily="34" charset="-122"/>
+                <a:cs typeface="Calibri" pitchFamily="34" charset="-120"/>
+              </a:rPr>
+              <a:t>• Security: every sensitive action behind role-based authorization</a:t>
+            </a:r>
+            <a:endParaRPr lang="en-US" sz="1250" dirty="0"/>
+          </a:p>
+        </p:txBody>
+      </p:sp>
+      <p:sp>
+        <p:nvSpPr>
+          <p:cNvPr id="102" name="Text 102"/>
+          <p:cNvSpPr/>
+          <p:nvPr/>
+        </p:nvSpPr>
+        <p:spPr>
+          <a:xfrm>
+            <a:off x="6583680" y="3893160"/>
+            <a:ext cx="4754880" cy="460000"/>
+          </a:xfrm>
+          <a:prstGeom prst="rect">
+            <a:avLst/>
+          </a:prstGeom>
+          <a:noFill/>
+          <a:ln/>
+        </p:spPr>
+        <p:txBody>
+          <a:bodyPr wrap="square" rtlCol="0" anchor="ctr"/>
+          <a:lstStyle/>
+          <a:p>
+            <a:pPr marL="0" indent="0">
+              <a:buNone/>
+            </a:pPr>
+            <a:r>
+              <a:rPr lang="en-US" sz="1250" dirty="0">
+                <a:solidFill>
+                  <a:srgbClr val="C7CAF2"/>
+                </a:solidFill>
+                <a:latin typeface="Calibri" pitchFamily="34" charset="0"/>
+                <a:ea typeface="Calibri" pitchFamily="34" charset="-122"/>
+                <a:cs typeface="Calibri" pitchFamily="34" charset="-120"/>
+              </a:rPr>
+              <a:t>• Maintainability: MVC separation &amp; a normalized data model</a:t>
+            </a:r>
+            <a:endParaRPr lang="en-US" sz="1250" dirty="0"/>
+          </a:p>
+        </p:txBody>
+      </p:sp>
+      <p:sp>
+        <p:nvSpPr>
+          <p:cNvPr id="103" name="Text 103"/>
+          <p:cNvSpPr/>
+          <p:nvPr/>
+        </p:nvSpPr>
+        <p:spPr>
+          <a:xfrm>
+            <a:off x="6583680" y="4383160"/>
+            <a:ext cx="4754880" cy="460000"/>
+          </a:xfrm>
+          <a:prstGeom prst="rect">
+            <a:avLst/>
+          </a:prstGeom>
+          <a:noFill/>
+          <a:ln/>
+        </p:spPr>
+        <p:txBody>
+          <a:bodyPr wrap="square" rtlCol="0" anchor="ctr"/>
+          <a:lstStyle/>
+          <a:p>
+            <a:pPr marL="0" indent="0">
+              <a:buNone/>
+            </a:pPr>
+            <a:r>
+              <a:rPr lang="en-US" sz="1250" dirty="0">
+                <a:solidFill>
+                  <a:srgbClr val="C7CAF2"/>
+                </a:solidFill>
+                <a:latin typeface="Calibri" pitchFamily="34" charset="0"/>
+                <a:ea typeface="Calibri" pitchFamily="34" charset="-122"/>
+                <a:cs typeface="Calibri" pitchFamily="34" charset="-120"/>
+              </a:rPr>
+              <a:t>• Dark, light &amp; custom colour themes for user comfort</a:t>
             </a:r>
             <a:endParaRPr lang="en-US" sz="1250" dirty="0"/>
           </a:p>
@@ -9058,7 +9828,7 @@
         <p:spPr>
           <a:xfrm>
             <a:off x="0" y="6784848"/>
-            <a:ext cx="1925005" cy="41148"/>
+            <a:ext cx="1828754" cy="41148"/>
           </a:xfrm>
           <a:prstGeom prst="rect">
             <a:avLst/>
@@ -9109,7 +9879,7 @@
                 <a:ea typeface="Calibri" pitchFamily="34" charset="-122"/>
                 <a:cs typeface="Calibri" pitchFamily="34" charset="-120"/>
               </a:rPr>
-              <a:t>03 / 19</a:t>
+              <a:t>03 / 20</a:t>
             </a:r>
             <a:endParaRPr lang="en-US" sz="1000" dirty="0"/>
           </a:p>
@@ -10023,7 +10793,7 @@
         <p:spPr>
           <a:xfrm>
             <a:off x="0" y="6784848"/>
-            <a:ext cx="2566673" cy="41148"/>
+            <a:ext cx="2438339" cy="41148"/>
           </a:xfrm>
           <a:prstGeom prst="rect">
             <a:avLst/>
@@ -10074,7 +10844,7 @@
                 <a:ea typeface="Calibri" pitchFamily="34" charset="-122"/>
                 <a:cs typeface="Calibri" pitchFamily="34" charset="-120"/>
               </a:rPr>
-              <a:t>04 / 19</a:t>
+              <a:t>04 / 20</a:t>
             </a:r>
             <a:endParaRPr lang="en-US" sz="1000" dirty="0"/>
           </a:p>
@@ -11230,7 +12000,7 @@
         <p:spPr>
           <a:xfrm>
             <a:off x="0" y="6784848"/>
-            <a:ext cx="3208341" cy="41148"/>
+            <a:ext cx="3047924" cy="41148"/>
           </a:xfrm>
           <a:prstGeom prst="rect">
             <a:avLst/>
@@ -11281,7 +12051,7 @@
                 <a:ea typeface="Calibri" pitchFamily="34" charset="-122"/>
                 <a:cs typeface="Calibri" pitchFamily="34" charset="-120"/>
               </a:rPr>
-              <a:t>05 / 19</a:t>
+              <a:t>05 / 20</a:t>
             </a:r>
             <a:endParaRPr lang="en-US" sz="1000" dirty="0"/>
           </a:p>
@@ -11792,7 +12562,7 @@
         <p:spPr>
           <a:xfrm>
             <a:off x="0" y="6784848"/>
-            <a:ext cx="3850009" cy="41148"/>
+            <a:ext cx="3657508" cy="41148"/>
           </a:xfrm>
           <a:prstGeom prst="rect">
             <a:avLst/>
@@ -11843,7 +12613,7 @@
                 <a:ea typeface="Calibri" pitchFamily="34" charset="-122"/>
                 <a:cs typeface="Calibri" pitchFamily="34" charset="-120"/>
               </a:rPr>
-              <a:t>06 / 19</a:t>
+              <a:t>06 / 20</a:t>
             </a:r>
             <a:endParaRPr lang="en-US" sz="1000" dirty="0"/>
           </a:p>
@@ -12666,7 +13436,7 @@
         <p:spPr>
           <a:xfrm>
             <a:off x="0" y="6784848"/>
-            <a:ext cx="4491677" cy="41148"/>
+            <a:ext cx="4267093" cy="41148"/>
           </a:xfrm>
           <a:prstGeom prst="rect">
             <a:avLst/>
@@ -12717,7 +13487,7 @@
                 <a:ea typeface="Calibri" pitchFamily="34" charset="-122"/>
                 <a:cs typeface="Calibri" pitchFamily="34" charset="-120"/>
               </a:rPr>
-              <a:t>07 / 19</a:t>
+              <a:t>07 / 20</a:t>
             </a:r>
             <a:endParaRPr lang="en-US" sz="1000" dirty="0"/>
           </a:p>
@@ -13692,7 +14462,7 @@
         <p:spPr>
           <a:xfrm>
             <a:off x="0" y="6784848"/>
-            <a:ext cx="5133345" cy="41148"/>
+            <a:ext cx="5486263" cy="41148"/>
           </a:xfrm>
           <a:prstGeom prst="rect">
             <a:avLst/>
@@ -13743,7 +14513,7 @@
                 <a:ea typeface="Calibri" pitchFamily="34" charset="-122"/>
                 <a:cs typeface="Calibri" pitchFamily="34" charset="-120"/>
               </a:rPr>
-              <a:t>08 / 19</a:t>
+              <a:t>09 / 20</a:t>
             </a:r>
             <a:endParaRPr lang="en-US" sz="1000" dirty="0"/>
           </a:p>
@@ -14447,7 +15217,7 @@
         <p:spPr>
           <a:xfrm>
             <a:off x="0" y="6784848"/>
-            <a:ext cx="5775014" cy="41148"/>
+            <a:ext cx="6095848" cy="41148"/>
           </a:xfrm>
           <a:prstGeom prst="rect">
             <a:avLst/>
@@ -14498,7 +15268,7 @@
                 <a:ea typeface="Calibri" pitchFamily="34" charset="-122"/>
                 <a:cs typeface="Calibri" pitchFamily="34" charset="-120"/>
               </a:rPr>
-              <a:t>09 / 19</a:t>
+              <a:t>10 / 20</a:t>
             </a:r>
             <a:endParaRPr lang="en-US" sz="1000" dirty="0"/>
           </a:p>

</xml_diff>

<commit_message>
Docs: bulk task actions, testing queue, account
Update ARCHITECTURE.md and README.md to document: multi-select bulk task actions (TaskController::bulkUpdate), the cross-project Testing Queue and its ordering, task freeze/reset behavior when a member leaves/deactivates/deleted and manager resolution flow, account deactivation vs deletion, admin-issued temporary passwords with forced change, and per-project/task notification muting. Also refreshes the delivered PPTX and DOCX artifacts.
</commit_message>
<xml_diff>
--- a/Synkro_PFA_Defense.pptx
+++ b/Synkro_PFA_Defense.pptx
@@ -3115,6 +3115,75 @@
           </a:p>
         </p:txBody>
       </p:sp>
+      <p:sp>
+        <p:nvSpPr>
+          <p:cNvPr id="100" name="Shape 98"/>
+          <p:cNvSpPr/>
+          <p:nvPr/>
+        </p:nvSpPr>
+        <p:spPr>
+          <a:xfrm>
+            <a:off x="548640" y="4663440"/>
+            <a:ext cx="82296" cy="82296"/>
+          </a:xfrm>
+          <a:prstGeom prst="ellipse">
+            <a:avLst/>
+          </a:prstGeom>
+          <a:solidFill>
+            <a:srgbClr val="4F46E5"/>
+          </a:solidFill>
+          <a:ln/>
+        </p:spPr>
+        <p:txBody>
+          <a:bodyPr/>
+          <a:lstStyle/>
+          <a:p>
+            <a:endParaRPr lang="en-US"/>
+          </a:p>
+        </p:txBody>
+      </p:sp>
+      <p:sp>
+        <p:nvSpPr>
+          <p:cNvPr id="101" name="Text 99"/>
+          <p:cNvSpPr/>
+          <p:nvPr/>
+        </p:nvSpPr>
+        <p:spPr>
+          <a:xfrm>
+            <a:off x="777240" y="4526280"/>
+            <a:ext cx="5029200" cy="502920"/>
+          </a:xfrm>
+          <a:prstGeom prst="rect">
+            <a:avLst/>
+          </a:prstGeom>
+          <a:noFill/>
+          <a:ln/>
+        </p:spPr>
+        <p:txBody>
+          <a:bodyPr wrap="square" rtlCol="0" anchor="ctr"/>
+          <a:lstStyle/>
+          <a:p>
+            <a:pPr marL="0" indent="0">
+              <a:lnSpc>
+                <a:spcPct val="120000"/>
+              </a:lnSpc>
+              <a:buNone/>
+            </a:pPr>
+            <a:r>
+              <a:rPr lang="en-US" sz="1300" dirty="0">
+                <a:solidFill>
+                  <a:srgbClr val="1F2430"/>
+                </a:solidFill>
+                <a:latin typeface="Calibri" pitchFamily="34" charset="0"/>
+                <a:ea typeface="Calibri" pitchFamily="34" charset="-122"/>
+                <a:cs typeface="Calibri" pitchFamily="34" charset="-120"/>
+              </a:rPr>
+              <a:t>Account deactivation, reactivated automatically on next login</a:t>
+            </a:r>
+            <a:endParaRPr lang="en-US" sz="1300" dirty="0"/>
+          </a:p>
+        </p:txBody>
+      </p:sp>
       <p:pic>
         <p:nvPicPr>
           <p:cNvPr id="16" name="Image 0" descr="/home/claude/work/build/assets/screenshot_sprint1_login.png"/>
@@ -3687,6 +3756,75 @@
           </a:p>
         </p:txBody>
       </p:sp>
+      <p:sp>
+        <p:nvSpPr>
+          <p:cNvPr id="100" name="Shape 98"/>
+          <p:cNvSpPr/>
+          <p:nvPr/>
+        </p:nvSpPr>
+        <p:spPr>
+          <a:xfrm>
+            <a:off x="548640" y="4663440"/>
+            <a:ext cx="82296" cy="82296"/>
+          </a:xfrm>
+          <a:prstGeom prst="ellipse">
+            <a:avLst/>
+          </a:prstGeom>
+          <a:solidFill>
+            <a:srgbClr val="4F46E5"/>
+          </a:solidFill>
+          <a:ln/>
+        </p:spPr>
+        <p:txBody>
+          <a:bodyPr/>
+          <a:lstStyle/>
+          <a:p>
+            <a:endParaRPr lang="en-US"/>
+          </a:p>
+        </p:txBody>
+      </p:sp>
+      <p:sp>
+        <p:nvSpPr>
+          <p:cNvPr id="101" name="Text 99"/>
+          <p:cNvSpPr/>
+          <p:nvPr/>
+        </p:nvSpPr>
+        <p:spPr>
+          <a:xfrm>
+            <a:off x="777240" y="4526280"/>
+            <a:ext cx="5029200" cy="502920"/>
+          </a:xfrm>
+          <a:prstGeom prst="rect">
+            <a:avLst/>
+          </a:prstGeom>
+          <a:noFill/>
+          <a:ln/>
+        </p:spPr>
+        <p:txBody>
+          <a:bodyPr wrap="square" rtlCol="0" anchor="ctr"/>
+          <a:lstStyle/>
+          <a:p>
+            <a:pPr marL="0" indent="0">
+              <a:lnSpc>
+                <a:spcPct val="120000"/>
+              </a:lnSpc>
+              <a:buNone/>
+            </a:pPr>
+            <a:r>
+              <a:rPr lang="en-US" sz="1300" dirty="0">
+                <a:solidFill>
+                  <a:srgbClr val="1F2430"/>
+                </a:solidFill>
+                <a:latin typeface="Calibri" pitchFamily="34" charset="0"/>
+                <a:ea typeface="Calibri" pitchFamily="34" charset="-122"/>
+                <a:cs typeface="Calibri" pitchFamily="34" charset="-120"/>
+              </a:rPr>
+              <a:t>Testing Queue and bulk task actions for reviewers and managers</a:t>
+            </a:r>
+            <a:endParaRPr lang="en-US" sz="1300" dirty="0"/>
+          </a:p>
+        </p:txBody>
+      </p:sp>
       <p:pic>
         <p:nvPicPr>
           <p:cNvPr id="16" name="Image 0" descr="/home/claude/work/build/assets/screenshot_sprint2_board.png"/>
@@ -4259,6 +4397,75 @@
           </a:p>
         </p:txBody>
       </p:sp>
+      <p:sp>
+        <p:nvSpPr>
+          <p:cNvPr id="100" name="Shape 98"/>
+          <p:cNvSpPr/>
+          <p:nvPr/>
+        </p:nvSpPr>
+        <p:spPr>
+          <a:xfrm>
+            <a:off x="548640" y="4663440"/>
+            <a:ext cx="82296" cy="82296"/>
+          </a:xfrm>
+          <a:prstGeom prst="ellipse">
+            <a:avLst/>
+          </a:prstGeom>
+          <a:solidFill>
+            <a:srgbClr val="4F46E5"/>
+          </a:solidFill>
+          <a:ln/>
+        </p:spPr>
+        <p:txBody>
+          <a:bodyPr/>
+          <a:lstStyle/>
+          <a:p>
+            <a:endParaRPr lang="en-US"/>
+          </a:p>
+        </p:txBody>
+      </p:sp>
+      <p:sp>
+        <p:nvSpPr>
+          <p:cNvPr id="101" name="Text 99"/>
+          <p:cNvSpPr/>
+          <p:nvPr/>
+        </p:nvSpPr>
+        <p:spPr>
+          <a:xfrm>
+            <a:off x="777240" y="4526280"/>
+            <a:ext cx="5029200" cy="502920"/>
+          </a:xfrm>
+          <a:prstGeom prst="rect">
+            <a:avLst/>
+          </a:prstGeom>
+          <a:noFill/>
+          <a:ln/>
+        </p:spPr>
+        <p:txBody>
+          <a:bodyPr wrap="square" rtlCol="0" anchor="ctr"/>
+          <a:lstStyle/>
+          <a:p>
+            <a:pPr marL="0" indent="0">
+              <a:lnSpc>
+                <a:spcPct val="120000"/>
+              </a:lnSpc>
+              <a:buNone/>
+            </a:pPr>
+            <a:r>
+              <a:rPr lang="en-US" sz="1300" dirty="0">
+                <a:solidFill>
+                  <a:srgbClr val="1F2430"/>
+                </a:solidFill>
+                <a:latin typeface="Calibri" pitchFamily="34" charset="0"/>
+                <a:ea typeface="Calibri" pitchFamily="34" charset="-122"/>
+                <a:cs typeface="Calibri" pitchFamily="34" charset="-120"/>
+              </a:rPr>
+              <a:t>Per-project and per-task notification muting</a:t>
+            </a:r>
+            <a:endParaRPr lang="en-US" sz="1300" dirty="0"/>
+          </a:p>
+        </p:txBody>
+      </p:sp>
       <p:pic>
         <p:nvPicPr>
           <p:cNvPr id="16" name="Image 0" descr="/home/claude/work/build/assets/screenshot_sprint3_notifications.png"/>
@@ -4826,6 +5033,75 @@
                 <a:cs typeface="Calibri" pitchFamily="34" charset="-120"/>
               </a:rPr>
               <a:t>Platform-wide analytics dashboard for admins</a:t>
+            </a:r>
+            <a:endParaRPr lang="en-US" sz="1300" dirty="0"/>
+          </a:p>
+        </p:txBody>
+      </p:sp>
+      <p:sp>
+        <p:nvSpPr>
+          <p:cNvPr id="100" name="Shape 98"/>
+          <p:cNvSpPr/>
+          <p:nvPr/>
+        </p:nvSpPr>
+        <p:spPr>
+          <a:xfrm>
+            <a:off x="548640" y="4663440"/>
+            <a:ext cx="82296" cy="82296"/>
+          </a:xfrm>
+          <a:prstGeom prst="ellipse">
+            <a:avLst/>
+          </a:prstGeom>
+          <a:solidFill>
+            <a:srgbClr val="4F46E5"/>
+          </a:solidFill>
+          <a:ln/>
+        </p:spPr>
+        <p:txBody>
+          <a:bodyPr/>
+          <a:lstStyle/>
+          <a:p>
+            <a:endParaRPr lang="en-US"/>
+          </a:p>
+        </p:txBody>
+      </p:sp>
+      <p:sp>
+        <p:nvSpPr>
+          <p:cNvPr id="101" name="Text 99"/>
+          <p:cNvSpPr/>
+          <p:nvPr/>
+        </p:nvSpPr>
+        <p:spPr>
+          <a:xfrm>
+            <a:off x="777240" y="4526280"/>
+            <a:ext cx="5029200" cy="502920"/>
+          </a:xfrm>
+          <a:prstGeom prst="rect">
+            <a:avLst/>
+          </a:prstGeom>
+          <a:noFill/>
+          <a:ln/>
+        </p:spPr>
+        <p:txBody>
+          <a:bodyPr wrap="square" rtlCol="0" anchor="ctr"/>
+          <a:lstStyle/>
+          <a:p>
+            <a:pPr marL="0" indent="0">
+              <a:lnSpc>
+                <a:spcPct val="120000"/>
+              </a:lnSpc>
+              <a:buNone/>
+            </a:pPr>
+            <a:r>
+              <a:rPr lang="en-US" sz="1300" dirty="0">
+                <a:solidFill>
+                  <a:srgbClr val="1F2430"/>
+                </a:solidFill>
+                <a:latin typeface="Calibri" pitchFamily="34" charset="0"/>
+                <a:ea typeface="Calibri" pitchFamily="34" charset="-122"/>
+                <a:cs typeface="Calibri" pitchFamily="34" charset="-120"/>
+              </a:rPr>
+              <a:t>Admin temporary passwords &amp; configurable feedback categories</a:t>
             </a:r>
             <a:endParaRPr lang="en-US" sz="1300" dirty="0"/>
           </a:p>

</xml_diff>

<commit_message>
Document login states and account-restore flow
Add ARCHITECTURE.md section describing how the login page (Auth/Login.jsx) surfaces multiple account states instead of a generic error: restorable soft-deleted accounts (6-digit inline restore code), admin-issued temporary-password flows (pending reset vs expired 24h token), and suspended accounts with embedded appeal and rate-limiting. Notes AuthenticatedSessionController behaviors (suspendedLogout/passwordResetLogout) that force users to the correct screen when sessions change. Update README to mention temp-password expiry and inline restore prompt. Also update two binary presentation/docx files.
</commit_message>
<xml_diff>
--- a/Synkro_PFA_Defense.pptx
+++ b/Synkro_PFA_Defense.pptx
@@ -3179,6 +3179,75 @@
                 <a:cs typeface="Calibri" pitchFamily="34" charset="-120"/>
               </a:rPr>
               <a:t>Account deactivation, reactivated automatically on next login</a:t>
+            </a:r>
+            <a:endParaRPr lang="en-US" sz="1300" dirty="0"/>
+          </a:p>
+        </p:txBody>
+      </p:sp>
+      <p:sp>
+        <p:nvSpPr>
+          <p:cNvPr id="200" name="Shape 198"/>
+          <p:cNvSpPr/>
+          <p:nvPr/>
+        </p:nvSpPr>
+        <p:spPr>
+          <a:xfrm>
+            <a:off x="548640" y="5321808"/>
+            <a:ext cx="82296" cy="82296"/>
+          </a:xfrm>
+          <a:prstGeom prst="ellipse">
+            <a:avLst/>
+          </a:prstGeom>
+          <a:solidFill>
+            <a:srgbClr val="4F46E5"/>
+          </a:solidFill>
+          <a:ln/>
+        </p:spPr>
+        <p:txBody>
+          <a:bodyPr/>
+          <a:lstStyle/>
+          <a:p>
+            <a:endParaRPr lang="en-US"/>
+          </a:p>
+        </p:txBody>
+      </p:sp>
+      <p:sp>
+        <p:nvSpPr>
+          <p:cNvPr id="201" name="Text 199"/>
+          <p:cNvSpPr/>
+          <p:nvPr/>
+        </p:nvSpPr>
+        <p:spPr>
+          <a:xfrm>
+            <a:off x="777240" y="5184648"/>
+            <a:ext cx="5029200" cy="502920"/>
+          </a:xfrm>
+          <a:prstGeom prst="rect">
+            <a:avLst/>
+          </a:prstGeom>
+          <a:noFill/>
+          <a:ln/>
+        </p:spPr>
+        <p:txBody>
+          <a:bodyPr wrap="square" rtlCol="0" anchor="ctr"/>
+          <a:lstStyle/>
+          <a:p>
+            <a:pPr marL="0" indent="0">
+              <a:lnSpc>
+                <a:spcPct val="120000"/>
+              </a:lnSpc>
+              <a:buNone/>
+            </a:pPr>
+            <a:r>
+              <a:rPr lang="en-US" sz="1300" dirty="0">
+                <a:solidFill>
+                  <a:srgbClr val="1F2430"/>
+                </a:solidFill>
+                <a:latin typeface="Calibri" pitchFamily="34" charset="0"/>
+                <a:ea typeface="Calibri" pitchFamily="34" charset="-122"/>
+                <a:cs typeface="Calibri" pitchFamily="34" charset="-120"/>
+              </a:rPr>
+              <a:t>On-page restore prompt when a deleted account tries to log in</a:t>
             </a:r>
             <a:endParaRPr lang="en-US" sz="1300" dirty="0"/>
           </a:p>

</xml_diff>

<commit_message>
Document dashboard filters and recovery flow
Updated architecture and product docs to describe the dashboard’s clickable chart legend as a comparison filter, the separate personal dashboard date-range controls, and the due-soon panel’s independent range filter. Also refreshed config and privacy/terms copy to match the account-recovery flow: soft-deleted accounts are restored via a 6-digit email code at login, not by simply signing back in.
</commit_message>
<xml_diff>
--- a/Synkro_PFA_Defense.pptx
+++ b/Synkro_PFA_Defense.pptx
@@ -4530,6 +4530,75 @@
                 <a:cs typeface="Calibri" pitchFamily="34" charset="-120"/>
               </a:rPr>
               <a:t>Per-project and per-task notification muting</a:t>
+            </a:r>
+            <a:endParaRPr lang="en-US" sz="1300" dirty="0"/>
+          </a:p>
+        </p:txBody>
+      </p:sp>
+      <p:sp>
+        <p:nvSpPr>
+          <p:cNvPr id="200" name="Shape 198"/>
+          <p:cNvSpPr/>
+          <p:nvPr/>
+        </p:nvSpPr>
+        <p:spPr>
+          <a:xfrm>
+            <a:off x="548640" y="5321808"/>
+            <a:ext cx="82296" cy="82296"/>
+          </a:xfrm>
+          <a:prstGeom prst="ellipse">
+            <a:avLst/>
+          </a:prstGeom>
+          <a:solidFill>
+            <a:srgbClr val="4F46E5"/>
+          </a:solidFill>
+          <a:ln/>
+        </p:spPr>
+        <p:txBody>
+          <a:bodyPr/>
+          <a:lstStyle/>
+          <a:p>
+            <a:endParaRPr lang="en-US"/>
+          </a:p>
+        </p:txBody>
+      </p:sp>
+      <p:sp>
+        <p:nvSpPr>
+          <p:cNvPr id="201" name="Text 199"/>
+          <p:cNvSpPr/>
+          <p:nvPr/>
+        </p:nvSpPr>
+        <p:spPr>
+          <a:xfrm>
+            <a:off x="777240" y="5184648"/>
+            <a:ext cx="5029200" cy="502920"/>
+          </a:xfrm>
+          <a:prstGeom prst="rect">
+            <a:avLst/>
+          </a:prstGeom>
+          <a:noFill/>
+          <a:ln/>
+        </p:spPr>
+        <p:txBody>
+          <a:bodyPr wrap="square" rtlCol="0" anchor="ctr"/>
+          <a:lstStyle/>
+          <a:p>
+            <a:pPr marL="0" indent="0">
+              <a:lnSpc>
+                <a:spcPct val="120000"/>
+              </a:lnSpc>
+              <a:buNone/>
+            </a:pPr>
+            <a:r>
+              <a:rPr lang="en-US" sz="1300" dirty="0">
+                <a:solidFill>
+                  <a:srgbClr val="1F2430"/>
+                </a:solidFill>
+                <a:latin typeface="Calibri" pitchFamily="34" charset="0"/>
+                <a:ea typeface="Calibri" pitchFamily="34" charset="-122"/>
+                <a:cs typeface="Calibri" pitchFamily="34" charset="-120"/>
+              </a:rPr>
+              <a:t>Personal dashboard: activity charts, calendars &amp; My Notes</a:t>
             </a:r>
             <a:endParaRPr lang="en-US" sz="1300" dirty="0"/>
           </a:p>

</xml_diff>